<commit_message>
fix: render Porter connectors in PowerPoint
</commit_message>
<xml_diff>
--- a/tests/quality/evidence/connectors/midnight-blue/connector-fixture.pptx
+++ b/tests/quality/evidence/connectors/midnight-blue/connector-fixture.pptx
@@ -4562,8 +4562,8 @@
           </p:nvCxnSpPr>
           <p:spPr>
             <a:xfrm>
-              <a:off x="0" y="0"/>
-              <a:ext cx="1" cy="1"/>
+              <a:off x="6096000" y="2913459"/>
+              <a:ext cx="1" cy="435135"/>
             </a:xfrm>
             <a:prstGeom prst="straightConnector1">
               <a:avLst/>
@@ -4586,9 +4586,9 @@
             <p:nvPr/>
           </p:nvCxnSpPr>
           <p:spPr>
-            <a:xfrm>
-              <a:off x="0" y="0"/>
-              <a:ext cx="1" cy="1"/>
+            <a:xfrm flipV="1">
+              <a:off x="6096000" y="4653995"/>
+              <a:ext cx="1" cy="435134"/>
             </a:xfrm>
             <a:prstGeom prst="straightConnector1">
               <a:avLst/>
@@ -4612,8 +4612,8 @@
           </p:nvCxnSpPr>
           <p:spPr>
             <a:xfrm>
-              <a:off x="0" y="0"/>
-              <a:ext cx="1" cy="1"/>
+              <a:off x="3782568" y="4001294"/>
+              <a:ext cx="736092" cy="1"/>
             </a:xfrm>
             <a:prstGeom prst="straightConnector1">
               <a:avLst/>
@@ -4636,9 +4636,9 @@
             <p:nvPr/>
           </p:nvCxnSpPr>
           <p:spPr>
-            <a:xfrm>
-              <a:off x="0" y="0"/>
-              <a:ext cx="1" cy="1"/>
+            <a:xfrm flipH="1">
+              <a:off x="7673340" y="4001294"/>
+              <a:ext cx="736092" cy="1"/>
             </a:xfrm>
             <a:prstGeom prst="straightConnector1">
               <a:avLst/>

</xml_diff>